<commit_message>
claims audit agent presentation
</commit_message>
<xml_diff>
--- a/Nandika Taneja Claims Audit Agent Presentation.pptx
+++ b/Nandika Taneja Claims Audit Agent Presentation.pptx
@@ -5,7 +5,7 @@
     <p:sldMasterId id="2147483648" r:id="rId1"/>
   </p:sldMasterIdLst>
   <p:notesMasterIdLst>
-    <p:notesMasterId r:id="rId11"/>
+    <p:notesMasterId r:id="rId13"/>
   </p:notesMasterIdLst>
   <p:sldIdLst>
     <p:sldId id="256" r:id="rId2"/>
@@ -16,7 +16,9 @@
     <p:sldId id="261" r:id="rId7"/>
     <p:sldId id="262" r:id="rId8"/>
     <p:sldId id="263" r:id="rId9"/>
-    <p:sldId id="264" r:id="rId10"/>
+    <p:sldId id="265" r:id="rId10"/>
+    <p:sldId id="266" r:id="rId11"/>
+    <p:sldId id="264" r:id="rId12"/>
   </p:sldIdLst>
   <p:sldSz cx="12192000" cy="6858000"/>
   <p:notesSz cx="6858000" cy="12192000"/>
@@ -311,6 +313,174 @@
             <a:fld id="{F7021451-1387-4CA6-816F-3879F97B5CBC}" type="slidenum">
               <a:rPr lang="en-US"/>
               <a:t>1</a:t>
+            </a:fld>
+            <a:endParaRPr lang="en-US"/>
+          </a:p>
+        </p:txBody>
+      </p:sp>
+    </p:spTree>
+    <p:extLst>
+      <p:ext uri="{BB962C8B-B14F-4D97-AF65-F5344CB8AC3E}">
+        <p14:creationId xmlns:p14="http://schemas.microsoft.com/office/powerpoint/2010/main" val="1024086991"/>
+      </p:ext>
+    </p:extLst>
+  </p:cSld>
+  <p:clrMapOvr>
+    <a:masterClrMapping/>
+  </p:clrMapOvr>
+</p:notes>
+</file>
+
+<file path=ppt/notesSlides/notesSlide10.xml><?xml version="1.0" encoding="utf-8"?>
+<p:notes xmlns:a="http://schemas.openxmlformats.org/drawingml/2006/main" xmlns:r="http://schemas.openxmlformats.org/officeDocument/2006/relationships" xmlns:p="http://schemas.openxmlformats.org/presentationml/2006/main">
+  <p:cSld>
+    <p:spTree>
+      <p:nvGrpSpPr>
+        <p:cNvPr id="1" name=""/>
+        <p:cNvGrpSpPr/>
+        <p:nvPr/>
+      </p:nvGrpSpPr>
+      <p:grpSpPr>
+        <a:xfrm>
+          <a:off x="0" y="0"/>
+          <a:ext cx="0" cy="0"/>
+          <a:chOff x="0" y="0"/>
+          <a:chExt cx="0" cy="0"/>
+        </a:xfrm>
+      </p:grpSpPr>
+      <p:sp>
+        <p:nvSpPr>
+          <p:cNvPr id="2" name="Slide Image Placeholder 1"/>
+          <p:cNvSpPr>
+            <a:spLocks noGrp="1" noRot="1" noChangeAspect="1"/>
+          </p:cNvSpPr>
+          <p:nvPr>
+            <p:ph type="sldImg"/>
+          </p:nvPr>
+        </p:nvSpPr>
+        <p:spPr/>
+      </p:sp>
+      <p:sp>
+        <p:nvSpPr>
+          <p:cNvPr id="3" name="Notes Placeholder 2"/>
+          <p:cNvSpPr>
+            <a:spLocks noGrp="1"/>
+          </p:cNvSpPr>
+          <p:nvPr>
+            <p:ph type="body" idx="1"/>
+          </p:nvPr>
+        </p:nvSpPr>
+        <p:spPr/>
+        <p:txBody>
+          <a:bodyPr/>
+          <a:lstStyle/>
+          <a:p>
+            <a:endParaRPr lang="en-US" dirty="0"/>
+          </a:p>
+        </p:txBody>
+      </p:sp>
+      <p:sp>
+        <p:nvSpPr>
+          <p:cNvPr id="4" name="Slide Number Placeholder 3"/>
+          <p:cNvSpPr>
+            <a:spLocks noGrp="1"/>
+          </p:cNvSpPr>
+          <p:nvPr>
+            <p:ph type="sldNum" sz="quarter" idx="10"/>
+          </p:nvPr>
+        </p:nvSpPr>
+        <p:spPr/>
+        <p:txBody>
+          <a:bodyPr/>
+          <a:lstStyle/>
+          <a:p>
+            <a:fld id="{F7021451-1387-4CA6-816F-3879F97B5CBC}" type="slidenum">
+              <a:rPr lang="en-US"/>
+              <a:t>10</a:t>
+            </a:fld>
+            <a:endParaRPr lang="en-US"/>
+          </a:p>
+        </p:txBody>
+      </p:sp>
+    </p:spTree>
+    <p:extLst>
+      <p:ext uri="{BB962C8B-B14F-4D97-AF65-F5344CB8AC3E}">
+        <p14:creationId xmlns:p14="http://schemas.microsoft.com/office/powerpoint/2010/main" val="1024086991"/>
+      </p:ext>
+    </p:extLst>
+  </p:cSld>
+  <p:clrMapOvr>
+    <a:masterClrMapping/>
+  </p:clrMapOvr>
+</p:notes>
+</file>
+
+<file path=ppt/notesSlides/notesSlide11.xml><?xml version="1.0" encoding="utf-8"?>
+<p:notes xmlns:a="http://schemas.openxmlformats.org/drawingml/2006/main" xmlns:r="http://schemas.openxmlformats.org/officeDocument/2006/relationships" xmlns:p="http://schemas.openxmlformats.org/presentationml/2006/main">
+  <p:cSld>
+    <p:spTree>
+      <p:nvGrpSpPr>
+        <p:cNvPr id="1" name=""/>
+        <p:cNvGrpSpPr/>
+        <p:nvPr/>
+      </p:nvGrpSpPr>
+      <p:grpSpPr>
+        <a:xfrm>
+          <a:off x="0" y="0"/>
+          <a:ext cx="0" cy="0"/>
+          <a:chOff x="0" y="0"/>
+          <a:chExt cx="0" cy="0"/>
+        </a:xfrm>
+      </p:grpSpPr>
+      <p:sp>
+        <p:nvSpPr>
+          <p:cNvPr id="2" name="Slide Image Placeholder 1"/>
+          <p:cNvSpPr>
+            <a:spLocks noGrp="1" noRot="1" noChangeAspect="1"/>
+          </p:cNvSpPr>
+          <p:nvPr>
+            <p:ph type="sldImg"/>
+          </p:nvPr>
+        </p:nvSpPr>
+        <p:spPr/>
+      </p:sp>
+      <p:sp>
+        <p:nvSpPr>
+          <p:cNvPr id="3" name="Notes Placeholder 2"/>
+          <p:cNvSpPr>
+            <a:spLocks noGrp="1"/>
+          </p:cNvSpPr>
+          <p:nvPr>
+            <p:ph type="body" idx="1"/>
+          </p:nvPr>
+        </p:nvSpPr>
+        <p:spPr/>
+        <p:txBody>
+          <a:bodyPr/>
+          <a:lstStyle/>
+          <a:p>
+            <a:endParaRPr lang="en-US" dirty="0"/>
+          </a:p>
+        </p:txBody>
+      </p:sp>
+      <p:sp>
+        <p:nvSpPr>
+          <p:cNvPr id="4" name="Slide Number Placeholder 3"/>
+          <p:cNvSpPr>
+            <a:spLocks noGrp="1"/>
+          </p:cNvSpPr>
+          <p:nvPr>
+            <p:ph type="sldNum" sz="quarter" idx="10"/>
+          </p:nvPr>
+        </p:nvSpPr>
+        <p:spPr/>
+        <p:txBody>
+          <a:bodyPr/>
+          <a:lstStyle/>
+          <a:p>
+            <a:fld id="{F7021451-1387-4CA6-816F-3879F97B5CBC}" type="slidenum">
+              <a:rPr lang="en-US"/>
+              <a:t>11</a:t>
             </a:fld>
             <a:endParaRPr lang="en-US"/>
           </a:p>
@@ -1607,6 +1777,1282 @@
 </p:sld>
 </file>
 
+<file path=ppt/slides/slide10.xml><?xml version="1.0" encoding="utf-8"?>
+<p:sld xmlns:a="http://schemas.openxmlformats.org/drawingml/2006/main" xmlns:r="http://schemas.openxmlformats.org/officeDocument/2006/relationships" xmlns:p="http://schemas.openxmlformats.org/presentationml/2006/main">
+  <p:cSld>
+    <p:spTree>
+      <p:nvGrpSpPr>
+        <p:cNvPr id="1" name=""/>
+        <p:cNvGrpSpPr/>
+        <p:nvPr/>
+      </p:nvGrpSpPr>
+      <p:grpSpPr>
+        <a:xfrm>
+          <a:off x="0" y="0"/>
+          <a:ext cx="0" cy="0"/>
+          <a:chOff x="0" y="0"/>
+          <a:chExt cx="0" cy="0"/>
+        </a:xfrm>
+      </p:grpSpPr>
+      <p:sp>
+        <p:nvSpPr>
+          <p:cNvPr id="2" name="Shape 0"/>
+          <p:cNvSpPr/>
+          <p:nvPr/>
+        </p:nvSpPr>
+        <p:spPr>
+          <a:xfrm>
+            <a:off x="-2286000" y="-2560320"/>
+            <a:ext cx="5486400" cy="5486400"/>
+          </a:xfrm>
+          <a:prstGeom prst="ellipse">
+            <a:avLst/>
+          </a:prstGeom>
+          <a:solidFill>
+            <a:srgbClr val="2D2A6E"/>
+          </a:solidFill>
+          <a:ln/>
+        </p:spPr>
+      </p:sp>
+      <p:sp>
+        <p:nvSpPr>
+          <p:cNvPr id="3" name="Text 1"/>
+          <p:cNvSpPr/>
+          <p:nvPr/>
+        </p:nvSpPr>
+        <p:spPr>
+          <a:xfrm>
+            <a:off x="548640" y="457200"/>
+            <a:ext cx="10058400" cy="640080"/>
+          </a:xfrm>
+          <a:prstGeom prst="rect">
+            <a:avLst/>
+          </a:prstGeom>
+          <a:noFill/>
+          <a:ln/>
+        </p:spPr>
+        <p:txBody>
+          <a:bodyPr wrap="square" rtlCol="0" anchor="ctr"/>
+          <a:lstStyle/>
+          <a:p>
+            <a:pPr marL="0" indent="0">
+              <a:buNone/>
+            </a:pPr>
+            <a:r>
+              <a:rPr lang="en-US" sz="2800" b="1" dirty="0">
+                <a:solidFill>
+                  <a:srgbClr val="FFFFFF"/>
+                </a:solidFill>
+                <a:latin typeface="Cambria" pitchFamily="34" charset="0"/>
+                <a:ea typeface="Cambria" pitchFamily="34" charset="-122"/>
+                <a:cs typeface="Cambria" pitchFamily="34" charset="-120"/>
+              </a:rPr>
+              <a:t>Future Scope</a:t>
+            </a:r>
+            <a:endParaRPr lang="en-US" sz="2800" dirty="0"/>
+          </a:p>
+        </p:txBody>
+      </p:sp>
+      <p:sp>
+        <p:nvSpPr>
+          <p:cNvPr id="4" name="Text 2"/>
+          <p:cNvSpPr/>
+          <p:nvPr/>
+        </p:nvSpPr>
+        <p:spPr>
+          <a:xfrm>
+            <a:off x="548640" y="1005840"/>
+            <a:ext cx="9144000" cy="365760"/>
+          </a:xfrm>
+          <a:prstGeom prst="rect">
+            <a:avLst/>
+          </a:prstGeom>
+          <a:noFill/>
+          <a:ln/>
+        </p:spPr>
+        <p:txBody>
+          <a:bodyPr wrap="square" rtlCol="0" anchor="ctr"/>
+          <a:lstStyle/>
+          <a:p>
+            <a:pPr marL="0" indent="0">
+              <a:buNone/>
+            </a:pPr>
+            <a:r>
+              <a:rPr lang="en-US" sz="1400" i="1" dirty="0">
+                <a:solidFill>
+                  <a:srgbClr val="C7C5EE"/>
+                </a:solidFill>
+                <a:latin typeface="Calibri" pitchFamily="34" charset="0"/>
+                <a:ea typeface="Calibri" pitchFamily="34" charset="-122"/>
+                <a:cs typeface="Calibri" pitchFamily="34" charset="-120"/>
+              </a:rPr>
+              <a:t>Six directions to take this POC toward a production capability</a:t>
+            </a:r>
+            <a:endParaRPr lang="en-US" sz="1400" dirty="0"/>
+          </a:p>
+        </p:txBody>
+      </p:sp>
+      <p:sp>
+        <p:nvSpPr>
+          <p:cNvPr id="5" name="Shape 3"/>
+          <p:cNvSpPr/>
+          <p:nvPr/>
+        </p:nvSpPr>
+        <p:spPr>
+          <a:xfrm>
+            <a:off x="548640" y="1691640"/>
+            <a:ext cx="3520440" cy="1965960"/>
+          </a:xfrm>
+          <a:prstGeom prst="roundRect">
+            <a:avLst>
+              <a:gd name="adj" fmla="val 4186"/>
+            </a:avLst>
+          </a:prstGeom>
+          <a:solidFill>
+            <a:srgbClr val="26225C"/>
+          </a:solidFill>
+          <a:ln/>
+        </p:spPr>
+      </p:sp>
+      <p:sp>
+        <p:nvSpPr>
+          <p:cNvPr id="6" name="Shape 4"/>
+          <p:cNvSpPr/>
+          <p:nvPr/>
+        </p:nvSpPr>
+        <p:spPr>
+          <a:xfrm>
+            <a:off x="804672" y="1929384"/>
+            <a:ext cx="457200" cy="457200"/>
+          </a:xfrm>
+          <a:prstGeom prst="ellipse">
+            <a:avLst/>
+          </a:prstGeom>
+          <a:solidFill>
+            <a:srgbClr val="3730A3"/>
+          </a:solidFill>
+          <a:ln/>
+        </p:spPr>
+      </p:sp>
+      <p:pic>
+        <p:nvPicPr>
+          <p:cNvPr id="7" name="Image 0" descr="preencoded.png"/>
+          <p:cNvPicPr>
+            <a:picLocks noChangeAspect="1"/>
+          </p:cNvPicPr>
+          <p:nvPr/>
+        </p:nvPicPr>
+        <p:blipFill>
+          <a:blip r:embed="rId3"/>
+          <a:stretch>
+            <a:fillRect/>
+          </a:stretch>
+        </p:blipFill>
+        <p:spPr>
+          <a:xfrm>
+            <a:off x="923544" y="2048256"/>
+            <a:ext cx="219456" cy="219456"/>
+          </a:xfrm>
+          <a:prstGeom prst="rect">
+            <a:avLst/>
+          </a:prstGeom>
+        </p:spPr>
+      </p:pic>
+      <p:sp>
+        <p:nvSpPr>
+          <p:cNvPr id="8" name="Text 5"/>
+          <p:cNvSpPr/>
+          <p:nvPr/>
+        </p:nvSpPr>
+        <p:spPr>
+          <a:xfrm>
+            <a:off x="804672" y="2496312"/>
+            <a:ext cx="3008376" cy="365760"/>
+          </a:xfrm>
+          <a:prstGeom prst="rect">
+            <a:avLst/>
+          </a:prstGeom>
+          <a:noFill/>
+          <a:ln/>
+        </p:spPr>
+        <p:txBody>
+          <a:bodyPr wrap="square" rtlCol="0" anchor="t"/>
+          <a:lstStyle/>
+          <a:p>
+            <a:pPr marL="0" indent="0">
+              <a:buNone/>
+            </a:pPr>
+            <a:r>
+              <a:rPr lang="en-US" sz="1350" b="1" dirty="0">
+                <a:solidFill>
+                  <a:srgbClr val="FFFFFF"/>
+                </a:solidFill>
+                <a:latin typeface="Cambria" pitchFamily="34" charset="0"/>
+                <a:ea typeface="Cambria" pitchFamily="34" charset="-122"/>
+                <a:cs typeface="Cambria" pitchFamily="34" charset="-120"/>
+              </a:rPr>
+              <a:t>Batch Claims Processing</a:t>
+            </a:r>
+            <a:endParaRPr lang="en-US" sz="1350" dirty="0"/>
+          </a:p>
+        </p:txBody>
+      </p:sp>
+      <p:sp>
+        <p:nvSpPr>
+          <p:cNvPr id="9" name="Text 6"/>
+          <p:cNvSpPr/>
+          <p:nvPr/>
+        </p:nvSpPr>
+        <p:spPr>
+          <a:xfrm>
+            <a:off x="804672" y="2880360"/>
+            <a:ext cx="3008376" cy="731520"/>
+          </a:xfrm>
+          <a:prstGeom prst="rect">
+            <a:avLst/>
+          </a:prstGeom>
+          <a:noFill/>
+          <a:ln/>
+        </p:spPr>
+        <p:txBody>
+          <a:bodyPr wrap="square" rtlCol="0" anchor="t"/>
+          <a:lstStyle/>
+          <a:p>
+            <a:pPr marL="0" indent="0">
+              <a:lnSpc>
+                <a:spcPts val="1400"/>
+              </a:lnSpc>
+              <a:buNone/>
+            </a:pPr>
+            <a:r>
+              <a:rPr lang="en-US" sz="1050" dirty="0">
+                <a:solidFill>
+                  <a:srgbClr val="C7C5EE"/>
+                </a:solidFill>
+                <a:latin typeface="Calibri" pitchFamily="34" charset="0"/>
+                <a:ea typeface="Calibri" pitchFamily="34" charset="-122"/>
+                <a:cs typeface="Calibri" pitchFamily="34" charset="-120"/>
+              </a:rPr>
+              <a:t>Run audit chains across an entire uploaded CSV at once, with a summary dashboard instead of one claim at a time.</a:t>
+            </a:r>
+            <a:endParaRPr lang="en-US" sz="1050" dirty="0"/>
+          </a:p>
+        </p:txBody>
+      </p:sp>
+      <p:sp>
+        <p:nvSpPr>
+          <p:cNvPr id="10" name="Shape 7"/>
+          <p:cNvSpPr/>
+          <p:nvPr/>
+        </p:nvSpPr>
+        <p:spPr>
+          <a:xfrm>
+            <a:off x="4297680" y="1691640"/>
+            <a:ext cx="3520440" cy="1965960"/>
+          </a:xfrm>
+          <a:prstGeom prst="roundRect">
+            <a:avLst>
+              <a:gd name="adj" fmla="val 4186"/>
+            </a:avLst>
+          </a:prstGeom>
+          <a:solidFill>
+            <a:srgbClr val="26225C"/>
+          </a:solidFill>
+          <a:ln/>
+        </p:spPr>
+      </p:sp>
+      <p:sp>
+        <p:nvSpPr>
+          <p:cNvPr id="11" name="Shape 8"/>
+          <p:cNvSpPr/>
+          <p:nvPr/>
+        </p:nvSpPr>
+        <p:spPr>
+          <a:xfrm>
+            <a:off x="4553712" y="1929384"/>
+            <a:ext cx="457200" cy="457200"/>
+          </a:xfrm>
+          <a:prstGeom prst="ellipse">
+            <a:avLst/>
+          </a:prstGeom>
+          <a:solidFill>
+            <a:srgbClr val="3730A3"/>
+          </a:solidFill>
+          <a:ln/>
+        </p:spPr>
+      </p:sp>
+      <p:pic>
+        <p:nvPicPr>
+          <p:cNvPr id="12" name="Image 1" descr="preencoded.png"/>
+          <p:cNvPicPr>
+            <a:picLocks noChangeAspect="1"/>
+          </p:cNvPicPr>
+          <p:nvPr/>
+        </p:nvPicPr>
+        <p:blipFill>
+          <a:blip r:embed="rId4"/>
+          <a:stretch>
+            <a:fillRect/>
+          </a:stretch>
+        </p:blipFill>
+        <p:spPr>
+          <a:xfrm>
+            <a:off x="4672584" y="2048256"/>
+            <a:ext cx="219456" cy="219456"/>
+          </a:xfrm>
+          <a:prstGeom prst="rect">
+            <a:avLst/>
+          </a:prstGeom>
+        </p:spPr>
+      </p:pic>
+      <p:sp>
+        <p:nvSpPr>
+          <p:cNvPr id="13" name="Text 9"/>
+          <p:cNvSpPr/>
+          <p:nvPr/>
+        </p:nvSpPr>
+        <p:spPr>
+          <a:xfrm>
+            <a:off x="4553712" y="2496312"/>
+            <a:ext cx="3008376" cy="365760"/>
+          </a:xfrm>
+          <a:prstGeom prst="rect">
+            <a:avLst/>
+          </a:prstGeom>
+          <a:noFill/>
+          <a:ln/>
+        </p:spPr>
+        <p:txBody>
+          <a:bodyPr wrap="square" rtlCol="0" anchor="t"/>
+          <a:lstStyle/>
+          <a:p>
+            <a:pPr marL="0" indent="0">
+              <a:buNone/>
+            </a:pPr>
+            <a:r>
+              <a:rPr lang="en-US" sz="1350" b="1" dirty="0">
+                <a:solidFill>
+                  <a:srgbClr val="FFFFFF"/>
+                </a:solidFill>
+                <a:latin typeface="Cambria" pitchFamily="34" charset="0"/>
+                <a:ea typeface="Cambria" pitchFamily="34" charset="-122"/>
+                <a:cs typeface="Cambria" pitchFamily="34" charset="-120"/>
+              </a:rPr>
+              <a:t>Live Edifecs Integration</a:t>
+            </a:r>
+            <a:endParaRPr lang="en-US" sz="1350" dirty="0"/>
+          </a:p>
+        </p:txBody>
+      </p:sp>
+      <p:sp>
+        <p:nvSpPr>
+          <p:cNvPr id="14" name="Text 10"/>
+          <p:cNvSpPr/>
+          <p:nvPr/>
+        </p:nvSpPr>
+        <p:spPr>
+          <a:xfrm>
+            <a:off x="4553712" y="2880360"/>
+            <a:ext cx="3008376" cy="731520"/>
+          </a:xfrm>
+          <a:prstGeom prst="rect">
+            <a:avLst/>
+          </a:prstGeom>
+          <a:noFill/>
+          <a:ln/>
+        </p:spPr>
+        <p:txBody>
+          <a:bodyPr wrap="square" rtlCol="0" anchor="t"/>
+          <a:lstStyle/>
+          <a:p>
+            <a:pPr marL="0" indent="0">
+              <a:lnSpc>
+                <a:spcPts val="1400"/>
+              </a:lnSpc>
+              <a:buNone/>
+            </a:pPr>
+            <a:r>
+              <a:rPr lang="en-US" sz="1050" dirty="0">
+                <a:solidFill>
+                  <a:srgbClr val="C7C5EE"/>
+                </a:solidFill>
+                <a:latin typeface="Calibri" pitchFamily="34" charset="0"/>
+                <a:ea typeface="Calibri" pitchFamily="34" charset="-122"/>
+                <a:cs typeface="Calibri" pitchFamily="34" charset="-120"/>
+              </a:rPr>
+              <a:t>Replace static CSV uploads with a live query against Edifecs' unified claims and provider data layer.</a:t>
+            </a:r>
+            <a:endParaRPr lang="en-US" sz="1050" dirty="0"/>
+          </a:p>
+        </p:txBody>
+      </p:sp>
+      <p:sp>
+        <p:nvSpPr>
+          <p:cNvPr id="15" name="Shape 11"/>
+          <p:cNvSpPr/>
+          <p:nvPr/>
+        </p:nvSpPr>
+        <p:spPr>
+          <a:xfrm>
+            <a:off x="8046720" y="1691640"/>
+            <a:ext cx="3520440" cy="1965960"/>
+          </a:xfrm>
+          <a:prstGeom prst="roundRect">
+            <a:avLst>
+              <a:gd name="adj" fmla="val 4186"/>
+            </a:avLst>
+          </a:prstGeom>
+          <a:solidFill>
+            <a:srgbClr val="26225C"/>
+          </a:solidFill>
+          <a:ln/>
+        </p:spPr>
+      </p:sp>
+      <p:sp>
+        <p:nvSpPr>
+          <p:cNvPr id="16" name="Shape 12"/>
+          <p:cNvSpPr/>
+          <p:nvPr/>
+        </p:nvSpPr>
+        <p:spPr>
+          <a:xfrm>
+            <a:off x="8302752" y="1929384"/>
+            <a:ext cx="457200" cy="457200"/>
+          </a:xfrm>
+          <a:prstGeom prst="ellipse">
+            <a:avLst/>
+          </a:prstGeom>
+          <a:solidFill>
+            <a:srgbClr val="3730A3"/>
+          </a:solidFill>
+          <a:ln/>
+        </p:spPr>
+      </p:sp>
+      <p:pic>
+        <p:nvPicPr>
+          <p:cNvPr id="17" name="Image 2" descr="preencoded.png"/>
+          <p:cNvPicPr>
+            <a:picLocks noChangeAspect="1"/>
+          </p:cNvPicPr>
+          <p:nvPr/>
+        </p:nvPicPr>
+        <p:blipFill>
+          <a:blip r:embed="rId5"/>
+          <a:stretch>
+            <a:fillRect/>
+          </a:stretch>
+        </p:blipFill>
+        <p:spPr>
+          <a:xfrm>
+            <a:off x="8421624" y="2048256"/>
+            <a:ext cx="219456" cy="219456"/>
+          </a:xfrm>
+          <a:prstGeom prst="rect">
+            <a:avLst/>
+          </a:prstGeom>
+        </p:spPr>
+      </p:pic>
+      <p:sp>
+        <p:nvSpPr>
+          <p:cNvPr id="18" name="Text 13"/>
+          <p:cNvSpPr/>
+          <p:nvPr/>
+        </p:nvSpPr>
+        <p:spPr>
+          <a:xfrm>
+            <a:off x="8302752" y="2496312"/>
+            <a:ext cx="3008376" cy="365760"/>
+          </a:xfrm>
+          <a:prstGeom prst="rect">
+            <a:avLst/>
+          </a:prstGeom>
+          <a:noFill/>
+          <a:ln/>
+        </p:spPr>
+        <p:txBody>
+          <a:bodyPr wrap="square" rtlCol="0" anchor="t"/>
+          <a:lstStyle/>
+          <a:p>
+            <a:pPr marL="0" indent="0">
+              <a:buNone/>
+            </a:pPr>
+            <a:r>
+              <a:rPr lang="en-US" sz="1350" b="1" dirty="0">
+                <a:solidFill>
+                  <a:srgbClr val="FFFFFF"/>
+                </a:solidFill>
+                <a:latin typeface="Cambria" pitchFamily="34" charset="0"/>
+                <a:ea typeface="Cambria" pitchFamily="34" charset="-122"/>
+                <a:cs typeface="Cambria" pitchFamily="34" charset="-120"/>
+              </a:rPr>
+              <a:t>Exportable Audit Trail</a:t>
+            </a:r>
+            <a:endParaRPr lang="en-US" sz="1350" dirty="0"/>
+          </a:p>
+        </p:txBody>
+      </p:sp>
+      <p:sp>
+        <p:nvSpPr>
+          <p:cNvPr id="19" name="Text 14"/>
+          <p:cNvSpPr/>
+          <p:nvPr/>
+        </p:nvSpPr>
+        <p:spPr>
+          <a:xfrm>
+            <a:off x="8302752" y="2880360"/>
+            <a:ext cx="3008376" cy="731520"/>
+          </a:xfrm>
+          <a:prstGeom prst="rect">
+            <a:avLst/>
+          </a:prstGeom>
+          <a:noFill/>
+          <a:ln/>
+        </p:spPr>
+        <p:txBody>
+          <a:bodyPr wrap="square" rtlCol="0" anchor="t"/>
+          <a:lstStyle/>
+          <a:p>
+            <a:pPr marL="0" indent="0">
+              <a:lnSpc>
+                <a:spcPts val="1400"/>
+              </a:lnSpc>
+              <a:buNone/>
+            </a:pPr>
+            <a:r>
+              <a:rPr lang="en-US" sz="1050" dirty="0">
+                <a:solidFill>
+                  <a:srgbClr val="C7C5EE"/>
+                </a:solidFill>
+                <a:latin typeface="Calibri" pitchFamily="34" charset="0"/>
+                <a:ea typeface="Calibri" pitchFamily="34" charset="-122"/>
+                <a:cs typeface="Calibri" pitchFamily="34" charset="-120"/>
+              </a:rPr>
+              <a:t>Generate a structured, exportable rationale per claim for regulatory documentation and provider appeals.</a:t>
+            </a:r>
+            <a:endParaRPr lang="en-US" sz="1050" dirty="0"/>
+          </a:p>
+        </p:txBody>
+      </p:sp>
+      <p:sp>
+        <p:nvSpPr>
+          <p:cNvPr id="20" name="Shape 15"/>
+          <p:cNvSpPr/>
+          <p:nvPr/>
+        </p:nvSpPr>
+        <p:spPr>
+          <a:xfrm>
+            <a:off x="548640" y="3886200"/>
+            <a:ext cx="3520440" cy="1965960"/>
+          </a:xfrm>
+          <a:prstGeom prst="roundRect">
+            <a:avLst>
+              <a:gd name="adj" fmla="val 4186"/>
+            </a:avLst>
+          </a:prstGeom>
+          <a:solidFill>
+            <a:srgbClr val="26225C"/>
+          </a:solidFill>
+          <a:ln/>
+        </p:spPr>
+      </p:sp>
+      <p:sp>
+        <p:nvSpPr>
+          <p:cNvPr id="21" name="Shape 16"/>
+          <p:cNvSpPr/>
+          <p:nvPr/>
+        </p:nvSpPr>
+        <p:spPr>
+          <a:xfrm>
+            <a:off x="804672" y="4123944"/>
+            <a:ext cx="457200" cy="457200"/>
+          </a:xfrm>
+          <a:prstGeom prst="ellipse">
+            <a:avLst/>
+          </a:prstGeom>
+          <a:solidFill>
+            <a:srgbClr val="3730A3"/>
+          </a:solidFill>
+          <a:ln/>
+        </p:spPr>
+      </p:sp>
+      <p:pic>
+        <p:nvPicPr>
+          <p:cNvPr id="22" name="Image 3" descr="preencoded.png"/>
+          <p:cNvPicPr>
+            <a:picLocks noChangeAspect="1"/>
+          </p:cNvPicPr>
+          <p:nvPr/>
+        </p:nvPicPr>
+        <p:blipFill>
+          <a:blip r:embed="rId6"/>
+          <a:stretch>
+            <a:fillRect/>
+          </a:stretch>
+        </p:blipFill>
+        <p:spPr>
+          <a:xfrm>
+            <a:off x="923544" y="4242816"/>
+            <a:ext cx="219456" cy="219456"/>
+          </a:xfrm>
+          <a:prstGeom prst="rect">
+            <a:avLst/>
+          </a:prstGeom>
+        </p:spPr>
+      </p:pic>
+      <p:sp>
+        <p:nvSpPr>
+          <p:cNvPr id="23" name="Text 17"/>
+          <p:cNvSpPr/>
+          <p:nvPr/>
+        </p:nvSpPr>
+        <p:spPr>
+          <a:xfrm>
+            <a:off x="804672" y="4690872"/>
+            <a:ext cx="3008376" cy="365760"/>
+          </a:xfrm>
+          <a:prstGeom prst="rect">
+            <a:avLst/>
+          </a:prstGeom>
+          <a:noFill/>
+          <a:ln/>
+        </p:spPr>
+        <p:txBody>
+          <a:bodyPr wrap="square" rtlCol="0" anchor="t"/>
+          <a:lstStyle/>
+          <a:p>
+            <a:pPr marL="0" indent="0">
+              <a:buNone/>
+            </a:pPr>
+            <a:r>
+              <a:rPr lang="en-US" sz="1350" b="1" dirty="0">
+                <a:solidFill>
+                  <a:srgbClr val="FFFFFF"/>
+                </a:solidFill>
+                <a:latin typeface="Cambria" pitchFamily="34" charset="0"/>
+                <a:ea typeface="Cambria" pitchFamily="34" charset="-122"/>
+                <a:cs typeface="Cambria" pitchFamily="34" charset="-120"/>
+              </a:rPr>
+              <a:t>Confidence-Scored Routing</a:t>
+            </a:r>
+            <a:endParaRPr lang="en-US" sz="1350" dirty="0"/>
+          </a:p>
+        </p:txBody>
+      </p:sp>
+      <p:sp>
+        <p:nvSpPr>
+          <p:cNvPr id="24" name="Text 18"/>
+          <p:cNvSpPr/>
+          <p:nvPr/>
+        </p:nvSpPr>
+        <p:spPr>
+          <a:xfrm>
+            <a:off x="804672" y="5074920"/>
+            <a:ext cx="3008376" cy="731520"/>
+          </a:xfrm>
+          <a:prstGeom prst="rect">
+            <a:avLst/>
+          </a:prstGeom>
+          <a:noFill/>
+          <a:ln/>
+        </p:spPr>
+        <p:txBody>
+          <a:bodyPr wrap="square" rtlCol="0" anchor="t"/>
+          <a:lstStyle/>
+          <a:p>
+            <a:pPr marL="0" indent="0">
+              <a:lnSpc>
+                <a:spcPts val="1400"/>
+              </a:lnSpc>
+              <a:buNone/>
+            </a:pPr>
+            <a:r>
+              <a:rPr lang="en-US" sz="1050" dirty="0">
+                <a:solidFill>
+                  <a:srgbClr val="C7C5EE"/>
+                </a:solidFill>
+                <a:latin typeface="Calibri" pitchFamily="34" charset="0"/>
+                <a:ea typeface="Calibri" pitchFamily="34" charset="-122"/>
+                <a:cs typeface="Calibri" pitchFamily="34" charset="-120"/>
+              </a:rPr>
+              <a:t>Add a numeric confidence score per verdict so low-confidence cases auto-route to human review.</a:t>
+            </a:r>
+            <a:endParaRPr lang="en-US" sz="1050" dirty="0"/>
+          </a:p>
+        </p:txBody>
+      </p:sp>
+      <p:sp>
+        <p:nvSpPr>
+          <p:cNvPr id="25" name="Shape 19"/>
+          <p:cNvSpPr/>
+          <p:nvPr/>
+        </p:nvSpPr>
+        <p:spPr>
+          <a:xfrm>
+            <a:off x="4297680" y="3886200"/>
+            <a:ext cx="3520440" cy="1965960"/>
+          </a:xfrm>
+          <a:prstGeom prst="roundRect">
+            <a:avLst>
+              <a:gd name="adj" fmla="val 4186"/>
+            </a:avLst>
+          </a:prstGeom>
+          <a:solidFill>
+            <a:srgbClr val="26225C"/>
+          </a:solidFill>
+          <a:ln/>
+        </p:spPr>
+      </p:sp>
+      <p:sp>
+        <p:nvSpPr>
+          <p:cNvPr id="26" name="Shape 20"/>
+          <p:cNvSpPr/>
+          <p:nvPr/>
+        </p:nvSpPr>
+        <p:spPr>
+          <a:xfrm>
+            <a:off x="4553712" y="4123944"/>
+            <a:ext cx="457200" cy="457200"/>
+          </a:xfrm>
+          <a:prstGeom prst="ellipse">
+            <a:avLst/>
+          </a:prstGeom>
+          <a:solidFill>
+            <a:srgbClr val="3730A3"/>
+          </a:solidFill>
+          <a:ln/>
+        </p:spPr>
+      </p:sp>
+      <p:pic>
+        <p:nvPicPr>
+          <p:cNvPr id="27" name="Image 4" descr="preencoded.png"/>
+          <p:cNvPicPr>
+            <a:picLocks noChangeAspect="1"/>
+          </p:cNvPicPr>
+          <p:nvPr/>
+        </p:nvPicPr>
+        <p:blipFill>
+          <a:blip r:embed="rId7"/>
+          <a:stretch>
+            <a:fillRect/>
+          </a:stretch>
+        </p:blipFill>
+        <p:spPr>
+          <a:xfrm>
+            <a:off x="4672584" y="4242816"/>
+            <a:ext cx="219456" cy="219456"/>
+          </a:xfrm>
+          <a:prstGeom prst="rect">
+            <a:avLst/>
+          </a:prstGeom>
+        </p:spPr>
+      </p:pic>
+      <p:sp>
+        <p:nvSpPr>
+          <p:cNvPr id="28" name="Text 21"/>
+          <p:cNvSpPr/>
+          <p:nvPr/>
+        </p:nvSpPr>
+        <p:spPr>
+          <a:xfrm>
+            <a:off x="4553712" y="4690872"/>
+            <a:ext cx="3008376" cy="365760"/>
+          </a:xfrm>
+          <a:prstGeom prst="rect">
+            <a:avLst/>
+          </a:prstGeom>
+          <a:noFill/>
+          <a:ln/>
+        </p:spPr>
+        <p:txBody>
+          <a:bodyPr wrap="square" rtlCol="0" anchor="t"/>
+          <a:lstStyle/>
+          <a:p>
+            <a:pPr marL="0" indent="0">
+              <a:buNone/>
+            </a:pPr>
+            <a:r>
+              <a:rPr lang="en-US" sz="1350" b="1" dirty="0">
+                <a:solidFill>
+                  <a:srgbClr val="FFFFFF"/>
+                </a:solidFill>
+                <a:latin typeface="Cambria" pitchFamily="34" charset="0"/>
+                <a:ea typeface="Cambria" pitchFamily="34" charset="-122"/>
+                <a:cs typeface="Cambria" pitchFamily="34" charset="-120"/>
+              </a:rPr>
+              <a:t>Provider Pattern Clustering</a:t>
+            </a:r>
+            <a:endParaRPr lang="en-US" sz="1350" dirty="0"/>
+          </a:p>
+        </p:txBody>
+      </p:sp>
+      <p:sp>
+        <p:nvSpPr>
+          <p:cNvPr id="29" name="Text 22"/>
+          <p:cNvSpPr/>
+          <p:nvPr/>
+        </p:nvSpPr>
+        <p:spPr>
+          <a:xfrm>
+            <a:off x="4553712" y="5074920"/>
+            <a:ext cx="3008376" cy="731520"/>
+          </a:xfrm>
+          <a:prstGeom prst="rect">
+            <a:avLst/>
+          </a:prstGeom>
+          <a:noFill/>
+          <a:ln/>
+        </p:spPr>
+        <p:txBody>
+          <a:bodyPr wrap="square" rtlCol="0" anchor="t"/>
+          <a:lstStyle/>
+          <a:p>
+            <a:pPr marL="0" indent="0">
+              <a:lnSpc>
+                <a:spcPts val="1400"/>
+              </a:lnSpc>
+              <a:buNone/>
+            </a:pPr>
+            <a:r>
+              <a:rPr lang="en-US" sz="1050" dirty="0">
+                <a:solidFill>
+                  <a:srgbClr val="C7C5EE"/>
+                </a:solidFill>
+                <a:latin typeface="Calibri" pitchFamily="34" charset="0"/>
+                <a:ea typeface="Calibri" pitchFamily="34" charset="-122"/>
+                <a:cs typeface="Calibri" pitchFamily="34" charset="-120"/>
+              </a:rPr>
+              <a:t>Extend beyond single claims to flag providers with anomalous billing patterns across their full history.</a:t>
+            </a:r>
+            <a:endParaRPr lang="en-US" sz="1050" dirty="0"/>
+          </a:p>
+        </p:txBody>
+      </p:sp>
+      <p:sp>
+        <p:nvSpPr>
+          <p:cNvPr id="30" name="Shape 23"/>
+          <p:cNvSpPr/>
+          <p:nvPr/>
+        </p:nvSpPr>
+        <p:spPr>
+          <a:xfrm>
+            <a:off x="8046720" y="3886200"/>
+            <a:ext cx="3520440" cy="1965960"/>
+          </a:xfrm>
+          <a:prstGeom prst="roundRect">
+            <a:avLst>
+              <a:gd name="adj" fmla="val 4186"/>
+            </a:avLst>
+          </a:prstGeom>
+          <a:solidFill>
+            <a:srgbClr val="26225C"/>
+          </a:solidFill>
+          <a:ln/>
+        </p:spPr>
+      </p:sp>
+      <p:sp>
+        <p:nvSpPr>
+          <p:cNvPr id="31" name="Shape 24"/>
+          <p:cNvSpPr/>
+          <p:nvPr/>
+        </p:nvSpPr>
+        <p:spPr>
+          <a:xfrm>
+            <a:off x="8302752" y="4123944"/>
+            <a:ext cx="457200" cy="457200"/>
+          </a:xfrm>
+          <a:prstGeom prst="ellipse">
+            <a:avLst/>
+          </a:prstGeom>
+          <a:solidFill>
+            <a:srgbClr val="3730A3"/>
+          </a:solidFill>
+          <a:ln/>
+        </p:spPr>
+      </p:sp>
+      <p:pic>
+        <p:nvPicPr>
+          <p:cNvPr id="32" name="Image 5" descr="preencoded.png"/>
+          <p:cNvPicPr>
+            <a:picLocks noChangeAspect="1"/>
+          </p:cNvPicPr>
+          <p:nvPr/>
+        </p:nvPicPr>
+        <p:blipFill>
+          <a:blip r:embed="rId8"/>
+          <a:stretch>
+            <a:fillRect/>
+          </a:stretch>
+        </p:blipFill>
+        <p:spPr>
+          <a:xfrm>
+            <a:off x="8421624" y="4242816"/>
+            <a:ext cx="219456" cy="219456"/>
+          </a:xfrm>
+          <a:prstGeom prst="rect">
+            <a:avLst/>
+          </a:prstGeom>
+        </p:spPr>
+      </p:pic>
+      <p:sp>
+        <p:nvSpPr>
+          <p:cNvPr id="33" name="Text 25"/>
+          <p:cNvSpPr/>
+          <p:nvPr/>
+        </p:nvSpPr>
+        <p:spPr>
+          <a:xfrm>
+            <a:off x="8302752" y="4690872"/>
+            <a:ext cx="3008376" cy="365760"/>
+          </a:xfrm>
+          <a:prstGeom prst="rect">
+            <a:avLst/>
+          </a:prstGeom>
+          <a:noFill/>
+          <a:ln/>
+        </p:spPr>
+        <p:txBody>
+          <a:bodyPr wrap="square" rtlCol="0" anchor="t"/>
+          <a:lstStyle/>
+          <a:p>
+            <a:pPr marL="0" indent="0">
+              <a:buNone/>
+            </a:pPr>
+            <a:r>
+              <a:rPr lang="en-US" sz="1350" b="1" dirty="0">
+                <a:solidFill>
+                  <a:srgbClr val="FFFFFF"/>
+                </a:solidFill>
+                <a:latin typeface="Cambria" pitchFamily="34" charset="0"/>
+                <a:ea typeface="Cambria" pitchFamily="34" charset="-122"/>
+                <a:cs typeface="Cambria" pitchFamily="34" charset="-120"/>
+              </a:rPr>
+              <a:t>Policy-Grounded Reasoning</a:t>
+            </a:r>
+            <a:endParaRPr lang="en-US" sz="1350" dirty="0"/>
+          </a:p>
+        </p:txBody>
+      </p:sp>
+      <p:sp>
+        <p:nvSpPr>
+          <p:cNvPr id="34" name="Text 26"/>
+          <p:cNvSpPr/>
+          <p:nvPr/>
+        </p:nvSpPr>
+        <p:spPr>
+          <a:xfrm>
+            <a:off x="8302752" y="5074920"/>
+            <a:ext cx="3008376" cy="731520"/>
+          </a:xfrm>
+          <a:prstGeom prst="rect">
+            <a:avLst/>
+          </a:prstGeom>
+          <a:noFill/>
+          <a:ln/>
+        </p:spPr>
+        <p:txBody>
+          <a:bodyPr wrap="square" rtlCol="0" anchor="t"/>
+          <a:lstStyle/>
+          <a:p>
+            <a:pPr marL="0" indent="0">
+              <a:lnSpc>
+                <a:spcPts val="1400"/>
+              </a:lnSpc>
+              <a:buNone/>
+            </a:pPr>
+            <a:r>
+              <a:rPr lang="en-US" sz="1050" dirty="0">
+                <a:solidFill>
+                  <a:srgbClr val="C7C5EE"/>
+                </a:solidFill>
+                <a:latin typeface="Calibri" pitchFamily="34" charset="0"/>
+                <a:ea typeface="Calibri" pitchFamily="34" charset="-122"/>
+                <a:cs typeface="Calibri" pitchFamily="34" charset="-120"/>
+              </a:rPr>
+              <a:t>Ground classification in retrieved CMS policy text (RAG) so each verdict cites the specific clause that justified it.</a:t>
+            </a:r>
+            <a:endParaRPr lang="en-US" sz="1050" dirty="0"/>
+          </a:p>
+        </p:txBody>
+      </p:sp>
+    </p:spTree>
+  </p:cSld>
+  <p:clrMapOvr>
+    <a:masterClrMapping/>
+  </p:clrMapOvr>
+</p:sld>
+</file>
+
+<file path=ppt/slides/slide11.xml><?xml version="1.0" encoding="utf-8"?>
+<p:sld xmlns:a="http://schemas.openxmlformats.org/drawingml/2006/main" xmlns:r="http://schemas.openxmlformats.org/officeDocument/2006/relationships" xmlns:p="http://schemas.openxmlformats.org/presentationml/2006/main">
+  <p:cSld name="Slide 9">
+    <p:bg>
+      <p:bgPr>
+        <a:solidFill>
+          <a:srgbClr val="1E1B4B"/>
+        </a:solidFill>
+        <a:effectLst/>
+      </p:bgPr>
+    </p:bg>
+    <p:spTree>
+      <p:nvGrpSpPr>
+        <p:cNvPr id="1" name=""/>
+        <p:cNvGrpSpPr/>
+        <p:nvPr/>
+      </p:nvGrpSpPr>
+      <p:grpSpPr>
+        <a:xfrm>
+          <a:off x="0" y="0"/>
+          <a:ext cx="0" cy="0"/>
+          <a:chOff x="0" y="0"/>
+          <a:chExt cx="0" cy="0"/>
+        </a:xfrm>
+      </p:grpSpPr>
+      <p:sp>
+        <p:nvSpPr>
+          <p:cNvPr id="2" name="Shape 0"/>
+          <p:cNvSpPr/>
+          <p:nvPr/>
+        </p:nvSpPr>
+        <p:spPr>
+          <a:xfrm>
+            <a:off x="8778240" y="-2011680"/>
+            <a:ext cx="6400800" cy="6400800"/>
+          </a:xfrm>
+          <a:prstGeom prst="ellipse">
+            <a:avLst/>
+          </a:prstGeom>
+          <a:solidFill>
+            <a:srgbClr val="2D2A6E"/>
+          </a:solidFill>
+          <a:ln/>
+        </p:spPr>
+      </p:sp>
+      <p:sp>
+        <p:nvSpPr>
+          <p:cNvPr id="5" name="Text 2"/>
+          <p:cNvSpPr/>
+          <p:nvPr/>
+        </p:nvSpPr>
+        <p:spPr>
+          <a:xfrm>
+            <a:off x="640080" y="1783080"/>
+            <a:ext cx="8229600" cy="731520"/>
+          </a:xfrm>
+          <a:prstGeom prst="rect">
+            <a:avLst/>
+          </a:prstGeom>
+          <a:noFill/>
+          <a:ln/>
+        </p:spPr>
+        <p:txBody>
+          <a:bodyPr wrap="square" rtlCol="0" anchor="ctr"/>
+          <a:lstStyle/>
+          <a:p>
+            <a:pPr marL="0" indent="0">
+              <a:buNone/>
+            </a:pPr>
+            <a:r>
+              <a:rPr lang="en-US" sz="3600" b="1" dirty="0">
+                <a:solidFill>
+                  <a:srgbClr val="FFFFFF"/>
+                </a:solidFill>
+                <a:latin typeface="Cambria" pitchFamily="34" charset="0"/>
+                <a:ea typeface="Cambria" pitchFamily="34" charset="-122"/>
+                <a:cs typeface="Cambria" pitchFamily="34" charset="-120"/>
+              </a:rPr>
+              <a:t>Thank You</a:t>
+            </a:r>
+            <a:endParaRPr lang="en-US" sz="3600" dirty="0"/>
+          </a:p>
+        </p:txBody>
+      </p:sp>
+      <p:sp>
+        <p:nvSpPr>
+          <p:cNvPr id="6" name="Text 3"/>
+          <p:cNvSpPr/>
+          <p:nvPr/>
+        </p:nvSpPr>
+        <p:spPr>
+          <a:xfrm>
+            <a:off x="640080" y="2468880"/>
+            <a:ext cx="8229600" cy="457200"/>
+          </a:xfrm>
+          <a:prstGeom prst="rect">
+            <a:avLst/>
+          </a:prstGeom>
+          <a:noFill/>
+          <a:ln/>
+        </p:spPr>
+        <p:txBody>
+          <a:bodyPr wrap="square" rtlCol="0" anchor="ctr"/>
+          <a:lstStyle/>
+          <a:p>
+            <a:pPr marL="0" indent="0">
+              <a:buNone/>
+            </a:pPr>
+            <a:r>
+              <a:rPr lang="en-US" sz="1500" i="1" dirty="0">
+                <a:solidFill>
+                  <a:srgbClr val="C7C5EE"/>
+                </a:solidFill>
+                <a:latin typeface="Calibri" pitchFamily="34" charset="0"/>
+                <a:ea typeface="Calibri" pitchFamily="34" charset="-122"/>
+                <a:cs typeface="Calibri" pitchFamily="34" charset="-120"/>
+              </a:rPr>
+              <a:t>Questions and discussion welcome</a:t>
+            </a:r>
+            <a:endParaRPr lang="en-US" sz="1500" dirty="0"/>
+          </a:p>
+        </p:txBody>
+      </p:sp>
+      <p:sp>
+        <p:nvSpPr>
+          <p:cNvPr id="7" name="Shape 4"/>
+          <p:cNvSpPr/>
+          <p:nvPr/>
+        </p:nvSpPr>
+        <p:spPr>
+          <a:xfrm>
+            <a:off x="640080" y="3200400"/>
+            <a:ext cx="3657600" cy="0"/>
+          </a:xfrm>
+          <a:prstGeom prst="line">
+            <a:avLst/>
+          </a:prstGeom>
+          <a:noFill/>
+          <a:ln w="12700">
+            <a:solidFill>
+              <a:srgbClr val="44408A"/>
+            </a:solidFill>
+            <a:prstDash val="solid"/>
+          </a:ln>
+        </p:spPr>
+      </p:sp>
+      <p:sp>
+        <p:nvSpPr>
+          <p:cNvPr id="8" name="Text 5"/>
+          <p:cNvSpPr/>
+          <p:nvPr/>
+        </p:nvSpPr>
+        <p:spPr>
+          <a:xfrm>
+            <a:off x="640080" y="3429000"/>
+            <a:ext cx="8229600" cy="365760"/>
+          </a:xfrm>
+          <a:prstGeom prst="rect">
+            <a:avLst/>
+          </a:prstGeom>
+          <a:noFill/>
+          <a:ln/>
+        </p:spPr>
+        <p:txBody>
+          <a:bodyPr wrap="square" rtlCol="0" anchor="ctr"/>
+          <a:lstStyle/>
+          <a:p>
+            <a:pPr marL="0" indent="0">
+              <a:buNone/>
+            </a:pPr>
+            <a:r>
+              <a:rPr lang="en-US" sz="1200" dirty="0">
+                <a:solidFill>
+                  <a:srgbClr val="A5A3D6"/>
+                </a:solidFill>
+                <a:latin typeface="Calibri" pitchFamily="34" charset="0"/>
+                <a:ea typeface="Calibri" pitchFamily="34" charset="-122"/>
+                <a:cs typeface="Calibri" pitchFamily="34" charset="-120"/>
+              </a:rPr>
+              <a:t>Full source list available in the written report and GitHub repository.</a:t>
+            </a:r>
+            <a:endParaRPr lang="en-US" sz="1200" dirty="0"/>
+          </a:p>
+        </p:txBody>
+      </p:sp>
+      <p:sp>
+        <p:nvSpPr>
+          <p:cNvPr id="9" name="Text 6"/>
+          <p:cNvSpPr/>
+          <p:nvPr/>
+        </p:nvSpPr>
+        <p:spPr>
+          <a:xfrm>
+            <a:off x="640080" y="3794760"/>
+            <a:ext cx="9601200" cy="365760"/>
+          </a:xfrm>
+          <a:prstGeom prst="rect">
+            <a:avLst/>
+          </a:prstGeom>
+          <a:noFill/>
+          <a:ln/>
+        </p:spPr>
+        <p:txBody>
+          <a:bodyPr wrap="square" rtlCol="0" anchor="ctr"/>
+          <a:lstStyle/>
+          <a:p>
+            <a:pPr marL="0" indent="0">
+              <a:buNone/>
+            </a:pPr>
+            <a:r>
+              <a:rPr lang="en-US" sz="1100" dirty="0">
+                <a:solidFill>
+                  <a:srgbClr val="8E8CC4"/>
+                </a:solidFill>
+                <a:latin typeface="Calibri" pitchFamily="34" charset="0"/>
+                <a:ea typeface="Calibri" pitchFamily="34" charset="-122"/>
+                <a:cs typeface="Calibri" pitchFamily="34" charset="-120"/>
+              </a:rPr>
+              <a:t>Key sources: Deloitte Insights (2026) · NHCAA (2025) · Cotiviti Newsroom (2025) · BCG (2026) · Milliman (2025)</a:t>
+            </a:r>
+            <a:endParaRPr lang="en-US" sz="1100" dirty="0"/>
+          </a:p>
+        </p:txBody>
+      </p:sp>
+      <p:sp>
+        <p:nvSpPr>
+          <p:cNvPr id="10" name="Text 7"/>
+          <p:cNvSpPr/>
+          <p:nvPr/>
+        </p:nvSpPr>
+        <p:spPr>
+          <a:xfrm>
+            <a:off x="640080" y="6172200"/>
+            <a:ext cx="8229600" cy="365760"/>
+          </a:xfrm>
+          <a:prstGeom prst="rect">
+            <a:avLst/>
+          </a:prstGeom>
+          <a:noFill/>
+          <a:ln/>
+        </p:spPr>
+        <p:txBody>
+          <a:bodyPr wrap="square" rtlCol="0" anchor="ctr"/>
+          <a:lstStyle/>
+          <a:p>
+            <a:pPr marL="0" indent="0">
+              <a:buNone/>
+            </a:pPr>
+            <a:r>
+              <a:rPr lang="en-US" sz="1100" dirty="0">
+                <a:solidFill>
+                  <a:srgbClr val="8E8CC4"/>
+                </a:solidFill>
+                <a:latin typeface="Calibri" pitchFamily="34" charset="0"/>
+                <a:ea typeface="Calibri" pitchFamily="34" charset="-122"/>
+                <a:cs typeface="Calibri" pitchFamily="34" charset="-120"/>
+              </a:rPr>
+              <a:t>Nandika Taneja  ·  Arizona State University  ·  tanejanandika@gmail.com</a:t>
+            </a:r>
+            <a:endParaRPr lang="en-US" sz="1100" dirty="0"/>
+          </a:p>
+        </p:txBody>
+      </p:sp>
+    </p:spTree>
+  </p:cSld>
+  <p:clrMapOvr>
+    <a:masterClrMapping/>
+  </p:clrMapOvr>
+</p:sld>
+</file>
+
 <file path=ppt/slides/slide2.xml><?xml version="1.0" encoding="utf-8"?>
 <p:sld xmlns:a="http://schemas.openxmlformats.org/drawingml/2006/main" xmlns:r="http://schemas.openxmlformats.org/officeDocument/2006/relationships" xmlns:p="http://schemas.openxmlformats.org/presentationml/2006/main">
   <p:cSld name="Slide 2">
@@ -7387,15 +8833,7 @@
 
 <file path=ppt/slides/slide9.xml><?xml version="1.0" encoding="utf-8"?>
 <p:sld xmlns:a="http://schemas.openxmlformats.org/drawingml/2006/main" xmlns:r="http://schemas.openxmlformats.org/officeDocument/2006/relationships" xmlns:p="http://schemas.openxmlformats.org/presentationml/2006/main">
-  <p:cSld name="Slide 9">
-    <p:bg>
-      <p:bgPr>
-        <a:solidFill>
-          <a:srgbClr val="1E1B4B"/>
-        </a:solidFill>
-        <a:effectLst/>
-      </p:bgPr>
-    </p:bg>
+  <p:cSld>
     <p:spTree>
       <p:nvGrpSpPr>
         <p:cNvPr id="1" name=""/>
@@ -7412,34 +8850,14 @@
       </p:grpSpPr>
       <p:sp>
         <p:nvSpPr>
-          <p:cNvPr id="2" name="Shape 0"/>
-          <p:cNvSpPr/>
-          <p:nvPr/>
-        </p:nvSpPr>
-        <p:spPr>
-          <a:xfrm>
-            <a:off x="8778240" y="-2011680"/>
-            <a:ext cx="6400800" cy="6400800"/>
-          </a:xfrm>
-          <a:prstGeom prst="ellipse">
-            <a:avLst/>
-          </a:prstGeom>
-          <a:solidFill>
-            <a:srgbClr val="2D2A6E"/>
-          </a:solidFill>
-          <a:ln/>
-        </p:spPr>
-      </p:sp>
-      <p:sp>
-        <p:nvSpPr>
-          <p:cNvPr id="5" name="Text 2"/>
-          <p:cNvSpPr/>
-          <p:nvPr/>
-        </p:nvSpPr>
-        <p:spPr>
-          <a:xfrm>
-            <a:off x="640080" y="1783080"/>
-            <a:ext cx="8229600" cy="731520"/>
+          <p:cNvPr id="2" name="Text 0"/>
+          <p:cNvSpPr/>
+          <p:nvPr/>
+        </p:nvSpPr>
+        <p:spPr>
+          <a:xfrm>
+            <a:off x="548640" y="411480"/>
+            <a:ext cx="10058400" cy="640080"/>
           </a:xfrm>
           <a:prstGeom prst="rect">
             <a:avLst/>
@@ -7455,30 +8873,30 @@
               <a:buNone/>
             </a:pPr>
             <a:r>
-              <a:rPr lang="en-US" sz="3600" b="1" dirty="0">
-                <a:solidFill>
-                  <a:srgbClr val="FFFFFF"/>
+              <a:rPr lang="en-US" sz="2800" b="1" dirty="0">
+                <a:solidFill>
+                  <a:srgbClr val="1E1B4B"/>
                 </a:solidFill>
                 <a:latin typeface="Cambria" pitchFamily="34" charset="0"/>
                 <a:ea typeface="Cambria" pitchFamily="34" charset="-122"/>
                 <a:cs typeface="Cambria" pitchFamily="34" charset="-120"/>
               </a:rPr>
-              <a:t>Thank You</a:t>
-            </a:r>
-            <a:endParaRPr lang="en-US" sz="3600" dirty="0"/>
-          </a:p>
-        </p:txBody>
-      </p:sp>
-      <p:sp>
-        <p:nvSpPr>
-          <p:cNvPr id="6" name="Text 3"/>
-          <p:cNvSpPr/>
-          <p:nvPr/>
-        </p:nvSpPr>
-        <p:spPr>
-          <a:xfrm>
-            <a:off x="640080" y="2468880"/>
-            <a:ext cx="8229600" cy="457200"/>
+              <a:t>Who This Serves: User Stories</a:t>
+            </a:r>
+            <a:endParaRPr lang="en-US" sz="2800" dirty="0"/>
+          </a:p>
+        </p:txBody>
+      </p:sp>
+      <p:sp>
+        <p:nvSpPr>
+          <p:cNvPr id="3" name="Text 1"/>
+          <p:cNvSpPr/>
+          <p:nvPr/>
+        </p:nvSpPr>
+        <p:spPr>
+          <a:xfrm>
+            <a:off x="548640" y="960120"/>
+            <a:ext cx="8229600" cy="365760"/>
           </a:xfrm>
           <a:prstGeom prst="rect">
             <a:avLst/>
@@ -7494,38 +8912,42 @@
               <a:buNone/>
             </a:pPr>
             <a:r>
-              <a:rPr lang="en-US" sz="1500" i="1" dirty="0">
-                <a:solidFill>
-                  <a:srgbClr val="C7C5EE"/>
+              <a:rPr lang="en-US" sz="1400" i="1" dirty="0">
+                <a:solidFill>
+                  <a:srgbClr val="525252"/>
                 </a:solidFill>
                 <a:latin typeface="Calibri" pitchFamily="34" charset="0"/>
                 <a:ea typeface="Calibri" pitchFamily="34" charset="-122"/>
                 <a:cs typeface="Calibri" pitchFamily="34" charset="-120"/>
               </a:rPr>
-              <a:t>Questions and discussion welcome</a:t>
-            </a:r>
-            <a:endParaRPr lang="en-US" sz="1500" dirty="0"/>
-          </a:p>
-        </p:txBody>
-      </p:sp>
-      <p:sp>
-        <p:nvSpPr>
-          <p:cNvPr id="7" name="Shape 4"/>
-          <p:cNvSpPr/>
-          <p:nvPr/>
-        </p:nvSpPr>
-        <p:spPr>
-          <a:xfrm>
-            <a:off x="640080" y="3200400"/>
-            <a:ext cx="3657600" cy="0"/>
-          </a:xfrm>
-          <a:prstGeom prst="line">
-            <a:avLst/>
-          </a:prstGeom>
-          <a:noFill/>
+              <a:t>Five roles inside Cotiviti's payment integrity workflow</a:t>
+            </a:r>
+            <a:endParaRPr lang="en-US" sz="1400" dirty="0"/>
+          </a:p>
+        </p:txBody>
+      </p:sp>
+      <p:sp>
+        <p:nvSpPr>
+          <p:cNvPr id="4" name="Shape 2"/>
+          <p:cNvSpPr/>
+          <p:nvPr/>
+        </p:nvSpPr>
+        <p:spPr>
+          <a:xfrm>
+            <a:off x="548640" y="1627632"/>
+            <a:ext cx="11064240" cy="822960"/>
+          </a:xfrm>
+          <a:prstGeom prst="roundRect">
+            <a:avLst>
+              <a:gd name="adj" fmla="val 8889"/>
+            </a:avLst>
+          </a:prstGeom>
+          <a:solidFill>
+            <a:srgbClr val="FAFAF9"/>
+          </a:solidFill>
           <a:ln w="12700">
             <a:solidFill>
-              <a:srgbClr val="44408A"/>
+              <a:srgbClr val="ECECE9"/>
             </a:solidFill>
             <a:prstDash val="solid"/>
           </a:ln>
@@ -7533,14 +8955,100 @@
       </p:sp>
       <p:sp>
         <p:nvSpPr>
+          <p:cNvPr id="5" name="Shape 3"/>
+          <p:cNvSpPr/>
+          <p:nvPr/>
+        </p:nvSpPr>
+        <p:spPr>
+          <a:xfrm>
+            <a:off x="749808" y="1792224"/>
+            <a:ext cx="493776" cy="493776"/>
+          </a:xfrm>
+          <a:prstGeom prst="ellipse">
+            <a:avLst/>
+          </a:prstGeom>
+          <a:solidFill>
+            <a:srgbClr val="EDE9FE"/>
+          </a:solidFill>
+          <a:ln/>
+        </p:spPr>
+      </p:sp>
+      <p:pic>
+        <p:nvPicPr>
+          <p:cNvPr id="6" name="Image 0" descr="preencoded.png"/>
+          <p:cNvPicPr>
+            <a:picLocks noChangeAspect="1"/>
+          </p:cNvPicPr>
+          <p:nvPr/>
+        </p:nvPicPr>
+        <p:blipFill>
+          <a:blip r:embed="rId3"/>
+          <a:stretch>
+            <a:fillRect/>
+          </a:stretch>
+        </p:blipFill>
+        <p:spPr>
+          <a:xfrm>
+            <a:off x="878190" y="1920606"/>
+            <a:ext cx="237012" cy="237012"/>
+          </a:xfrm>
+          <a:prstGeom prst="rect">
+            <a:avLst/>
+          </a:prstGeom>
+        </p:spPr>
+      </p:pic>
+      <p:sp>
+        <p:nvSpPr>
+          <p:cNvPr id="7" name="Text 4"/>
+          <p:cNvSpPr/>
+          <p:nvPr/>
+        </p:nvSpPr>
+        <p:spPr>
+          <a:xfrm>
+            <a:off x="1417320" y="1719072"/>
+            <a:ext cx="2331720" cy="640080"/>
+          </a:xfrm>
+          <a:prstGeom prst="rect">
+            <a:avLst/>
+          </a:prstGeom>
+          <a:noFill/>
+          <a:ln/>
+        </p:spPr>
+        <p:txBody>
+          <a:bodyPr wrap="square" rtlCol="0" anchor="ctr"/>
+          <a:lstStyle/>
+          <a:p>
+            <a:pPr marL="0" indent="0">
+              <a:lnSpc>
+                <a:spcPts val="1600"/>
+              </a:lnSpc>
+              <a:buNone/>
+            </a:pPr>
+            <a:r>
+              <a:rPr lang="en-US" sz="1350" b="1" dirty="0">
+                <a:solidFill>
+                  <a:srgbClr val="1E1B4B"/>
+                </a:solidFill>
+                <a:latin typeface="Cambria" pitchFamily="34" charset="0"/>
+                <a:ea typeface="Cambria" pitchFamily="34" charset="-122"/>
+                <a:cs typeface="Cambria" pitchFamily="34" charset="-120"/>
+              </a:rPr>
+              <a:t>Payment Integrity Analyst</a:t>
+            </a:r>
+            <a:endParaRPr lang="en-US" sz="1350" dirty="0"/>
+          </a:p>
+        </p:txBody>
+      </p:sp>
+      <p:sp>
+        <p:nvSpPr>
           <p:cNvPr id="8" name="Text 5"/>
           <p:cNvSpPr/>
           <p:nvPr/>
         </p:nvSpPr>
         <p:spPr>
           <a:xfrm>
-            <a:off x="640080" y="3429000"/>
-            <a:ext cx="8229600" cy="365760"/>
+            <a:off x="3931920" y="1700784"/>
+            <a:ext cx="7406640" cy="676656"/>
           </a:xfrm>
           <a:prstGeom prst="rect">
             <a:avLst/>
@@ -7553,33 +9061,107 @@
           <a:lstStyle/>
           <a:p>
             <a:pPr marL="0" indent="0">
-              <a:buNone/>
-            </a:pPr>
-            <a:r>
-              <a:rPr lang="en-US" sz="1200" dirty="0">
-                <a:solidFill>
-                  <a:srgbClr val="A5A3D6"/>
+              <a:lnSpc>
+                <a:spcPts val="1500"/>
+              </a:lnSpc>
+              <a:buNone/>
+            </a:pPr>
+            <a:r>
+              <a:rPr lang="en-US" sz="1150" dirty="0">
+                <a:solidFill>
+                  <a:srgbClr val="1A1A1A"/>
                 </a:solidFill>
                 <a:latin typeface="Calibri" pitchFamily="34" charset="0"/>
                 <a:ea typeface="Calibri" pitchFamily="34" charset="-122"/>
                 <a:cs typeface="Calibri" pitchFamily="34" charset="-120"/>
               </a:rPr>
-              <a:t>Full source list available in the written report and GitHub repository.</a:t>
-            </a:r>
-            <a:endParaRPr lang="en-US" sz="1200" dirty="0"/>
-          </a:p>
-        </p:txBody>
-      </p:sp>
-      <p:sp>
-        <p:nvSpPr>
-          <p:cNvPr id="9" name="Text 6"/>
-          <p:cNvSpPr/>
-          <p:nvPr/>
-        </p:nvSpPr>
-        <p:spPr>
-          <a:xfrm>
-            <a:off x="640080" y="3794760"/>
-            <a:ext cx="9601200" cy="365760"/>
+              <a:t>As a payment integrity analyst, I want claims pre-triaged into approve, flag, or deny categories, so I can focus manual review time on the highest-risk claims first.</a:t>
+            </a:r>
+            <a:endParaRPr lang="en-US" sz="1150" dirty="0"/>
+          </a:p>
+        </p:txBody>
+      </p:sp>
+      <p:sp>
+        <p:nvSpPr>
+          <p:cNvPr id="9" name="Shape 6"/>
+          <p:cNvSpPr/>
+          <p:nvPr/>
+        </p:nvSpPr>
+        <p:spPr>
+          <a:xfrm>
+            <a:off x="548640" y="2560320"/>
+            <a:ext cx="11064240" cy="822960"/>
+          </a:xfrm>
+          <a:prstGeom prst="roundRect">
+            <a:avLst>
+              <a:gd name="adj" fmla="val 8889"/>
+            </a:avLst>
+          </a:prstGeom>
+          <a:solidFill>
+            <a:srgbClr val="FAFAF9"/>
+          </a:solidFill>
+          <a:ln w="12700">
+            <a:solidFill>
+              <a:srgbClr val="ECECE9"/>
+            </a:solidFill>
+            <a:prstDash val="solid"/>
+          </a:ln>
+        </p:spPr>
+      </p:sp>
+      <p:sp>
+        <p:nvSpPr>
+          <p:cNvPr id="10" name="Shape 7"/>
+          <p:cNvSpPr/>
+          <p:nvPr/>
+        </p:nvSpPr>
+        <p:spPr>
+          <a:xfrm>
+            <a:off x="749808" y="2724912"/>
+            <a:ext cx="493776" cy="493776"/>
+          </a:xfrm>
+          <a:prstGeom prst="ellipse">
+            <a:avLst/>
+          </a:prstGeom>
+          <a:solidFill>
+            <a:srgbClr val="FDF1DE"/>
+          </a:solidFill>
+          <a:ln/>
+        </p:spPr>
+      </p:sp>
+      <p:pic>
+        <p:nvPicPr>
+          <p:cNvPr id="11" name="Image 1" descr="preencoded.png"/>
+          <p:cNvPicPr>
+            <a:picLocks noChangeAspect="1"/>
+          </p:cNvPicPr>
+          <p:nvPr/>
+        </p:nvPicPr>
+        <p:blipFill>
+          <a:blip r:embed="rId4"/>
+          <a:stretch>
+            <a:fillRect/>
+          </a:stretch>
+        </p:blipFill>
+        <p:spPr>
+          <a:xfrm>
+            <a:off x="878190" y="2853294"/>
+            <a:ext cx="237012" cy="237012"/>
+          </a:xfrm>
+          <a:prstGeom prst="rect">
+            <a:avLst/>
+          </a:prstGeom>
+        </p:spPr>
+      </p:pic>
+      <p:sp>
+        <p:nvSpPr>
+          <p:cNvPr id="12" name="Text 8"/>
+          <p:cNvSpPr/>
+          <p:nvPr/>
+        </p:nvSpPr>
+        <p:spPr>
+          <a:xfrm>
+            <a:off x="1417320" y="2651760"/>
+            <a:ext cx="2331720" cy="640080"/>
           </a:xfrm>
           <a:prstGeom prst="rect">
             <a:avLst/>
@@ -7592,33 +9174,149 @@
           <a:lstStyle/>
           <a:p>
             <a:pPr marL="0" indent="0">
-              <a:buNone/>
-            </a:pPr>
-            <a:r>
-              <a:rPr lang="en-US" sz="1100" dirty="0">
-                <a:solidFill>
-                  <a:srgbClr val="8E8CC4"/>
+              <a:lnSpc>
+                <a:spcPts val="1600"/>
+              </a:lnSpc>
+              <a:buNone/>
+            </a:pPr>
+            <a:r>
+              <a:rPr lang="en-US" sz="1350" b="1" dirty="0">
+                <a:solidFill>
+                  <a:srgbClr val="1E1B4B"/>
+                </a:solidFill>
+                <a:latin typeface="Cambria" pitchFamily="34" charset="0"/>
+                <a:ea typeface="Cambria" pitchFamily="34" charset="-122"/>
+                <a:cs typeface="Cambria" pitchFamily="34" charset="-120"/>
+              </a:rPr>
+              <a:t>Audit Team Lead</a:t>
+            </a:r>
+            <a:endParaRPr lang="en-US" sz="1350" dirty="0"/>
+          </a:p>
+        </p:txBody>
+      </p:sp>
+      <p:sp>
+        <p:nvSpPr>
+          <p:cNvPr id="13" name="Text 9"/>
+          <p:cNvSpPr/>
+          <p:nvPr/>
+        </p:nvSpPr>
+        <p:spPr>
+          <a:xfrm>
+            <a:off x="3931920" y="2633472"/>
+            <a:ext cx="7406640" cy="676656"/>
+          </a:xfrm>
+          <a:prstGeom prst="rect">
+            <a:avLst/>
+          </a:prstGeom>
+          <a:noFill/>
+          <a:ln/>
+        </p:spPr>
+        <p:txBody>
+          <a:bodyPr wrap="square" rtlCol="0" anchor="ctr"/>
+          <a:lstStyle/>
+          <a:p>
+            <a:pPr marL="0" indent="0">
+              <a:lnSpc>
+                <a:spcPts val="1500"/>
+              </a:lnSpc>
+              <a:buNone/>
+            </a:pPr>
+            <a:r>
+              <a:rPr lang="en-US" sz="1150" dirty="0">
+                <a:solidFill>
+                  <a:srgbClr val="1A1A1A"/>
                 </a:solidFill>
                 <a:latin typeface="Calibri" pitchFamily="34" charset="0"/>
                 <a:ea typeface="Calibri" pitchFamily="34" charset="-122"/>
                 <a:cs typeface="Calibri" pitchFamily="34" charset="-120"/>
               </a:rPr>
-              <a:t>Key sources: Deloitte Insights (2026) · NHCAA (2025) · Cotiviti Newsroom (2025) · BCG (2026) · Milliman (2025)</a:t>
-            </a:r>
-            <a:endParaRPr lang="en-US" sz="1100" dirty="0"/>
-          </a:p>
-        </p:txBody>
-      </p:sp>
-      <p:sp>
-        <p:nvSpPr>
-          <p:cNvPr id="10" name="Text 7"/>
-          <p:cNvSpPr/>
-          <p:nvPr/>
-        </p:nvSpPr>
-        <p:spPr>
-          <a:xfrm>
-            <a:off x="640080" y="6172200"/>
-            <a:ext cx="8229600" cy="365760"/>
+              <a:t>As an audit team lead, I want each AI decision paired with a structured rationale, so I can defend denials during provider appeals.</a:t>
+            </a:r>
+            <a:endParaRPr lang="en-US" sz="1150" dirty="0"/>
+          </a:p>
+        </p:txBody>
+      </p:sp>
+      <p:sp>
+        <p:nvSpPr>
+          <p:cNvPr id="14" name="Shape 10"/>
+          <p:cNvSpPr/>
+          <p:nvPr/>
+        </p:nvSpPr>
+        <p:spPr>
+          <a:xfrm>
+            <a:off x="548640" y="3493008"/>
+            <a:ext cx="11064240" cy="822960"/>
+          </a:xfrm>
+          <a:prstGeom prst="roundRect">
+            <a:avLst>
+              <a:gd name="adj" fmla="val 8889"/>
+            </a:avLst>
+          </a:prstGeom>
+          <a:solidFill>
+            <a:srgbClr val="FAFAF9"/>
+          </a:solidFill>
+          <a:ln w="12700">
+            <a:solidFill>
+              <a:srgbClr val="ECECE9"/>
+            </a:solidFill>
+            <a:prstDash val="solid"/>
+          </a:ln>
+        </p:spPr>
+      </p:sp>
+      <p:sp>
+        <p:nvSpPr>
+          <p:cNvPr id="15" name="Shape 11"/>
+          <p:cNvSpPr/>
+          <p:nvPr/>
+        </p:nvSpPr>
+        <p:spPr>
+          <a:xfrm>
+            <a:off x="749808" y="3657600"/>
+            <a:ext cx="493776" cy="493776"/>
+          </a:xfrm>
+          <a:prstGeom prst="ellipse">
+            <a:avLst/>
+          </a:prstGeom>
+          <a:solidFill>
+            <a:srgbClr val="E5E4F7"/>
+          </a:solidFill>
+          <a:ln/>
+        </p:spPr>
+      </p:sp>
+      <p:pic>
+        <p:nvPicPr>
+          <p:cNvPr id="16" name="Image 2" descr="preencoded.png"/>
+          <p:cNvPicPr>
+            <a:picLocks noChangeAspect="1"/>
+          </p:cNvPicPr>
+          <p:nvPr/>
+        </p:nvPicPr>
+        <p:blipFill>
+          <a:blip r:embed="rId5"/>
+          <a:stretch>
+            <a:fillRect/>
+          </a:stretch>
+        </p:blipFill>
+        <p:spPr>
+          <a:xfrm>
+            <a:off x="878190" y="3785982"/>
+            <a:ext cx="237012" cy="237012"/>
+          </a:xfrm>
+          <a:prstGeom prst="rect">
+            <a:avLst/>
+          </a:prstGeom>
+        </p:spPr>
+      </p:pic>
+      <p:sp>
+        <p:nvSpPr>
+          <p:cNvPr id="17" name="Text 12"/>
+          <p:cNvSpPr/>
+          <p:nvPr/>
+        </p:nvSpPr>
+        <p:spPr>
+          <a:xfrm>
+            <a:off x="1417320" y="3584448"/>
+            <a:ext cx="2331720" cy="640080"/>
           </a:xfrm>
           <a:prstGeom prst="rect">
             <a:avLst/>
@@ -7631,20 +9329,375 @@
           <a:lstStyle/>
           <a:p>
             <a:pPr marL="0" indent="0">
-              <a:buNone/>
-            </a:pPr>
-            <a:r>
-              <a:rPr lang="en-US" sz="1100" dirty="0">
-                <a:solidFill>
-                  <a:srgbClr val="8E8CC4"/>
+              <a:lnSpc>
+                <a:spcPts val="1600"/>
+              </a:lnSpc>
+              <a:buNone/>
+            </a:pPr>
+            <a:r>
+              <a:rPr lang="en-US" sz="1350" b="1" dirty="0">
+                <a:solidFill>
+                  <a:srgbClr val="1E1B4B"/>
+                </a:solidFill>
+                <a:latin typeface="Cambria" pitchFamily="34" charset="0"/>
+                <a:ea typeface="Cambria" pitchFamily="34" charset="-122"/>
+                <a:cs typeface="Cambria" pitchFamily="34" charset="-120"/>
+              </a:rPr>
+              <a:t>Compliance Officer</a:t>
+            </a:r>
+            <a:endParaRPr lang="en-US" sz="1350" dirty="0"/>
+          </a:p>
+        </p:txBody>
+      </p:sp>
+      <p:sp>
+        <p:nvSpPr>
+          <p:cNvPr id="18" name="Text 13"/>
+          <p:cNvSpPr/>
+          <p:nvPr/>
+        </p:nvSpPr>
+        <p:spPr>
+          <a:xfrm>
+            <a:off x="3931920" y="3566160"/>
+            <a:ext cx="7406640" cy="676656"/>
+          </a:xfrm>
+          <a:prstGeom prst="rect">
+            <a:avLst/>
+          </a:prstGeom>
+          <a:noFill/>
+          <a:ln/>
+        </p:spPr>
+        <p:txBody>
+          <a:bodyPr wrap="square" rtlCol="0" anchor="ctr"/>
+          <a:lstStyle/>
+          <a:p>
+            <a:pPr marL="0" indent="0">
+              <a:lnSpc>
+                <a:spcPts val="1500"/>
+              </a:lnSpc>
+              <a:buNone/>
+            </a:pPr>
+            <a:r>
+              <a:rPr lang="en-US" sz="1150" dirty="0">
+                <a:solidFill>
+                  <a:srgbClr val="1A1A1A"/>
                 </a:solidFill>
                 <a:latin typeface="Calibri" pitchFamily="34" charset="0"/>
                 <a:ea typeface="Calibri" pitchFamily="34" charset="-122"/>
                 <a:cs typeface="Calibri" pitchFamily="34" charset="-120"/>
               </a:rPr>
-              <a:t>Nandika Taneja  ·  Arizona State University  ·  tanejanandika@gmail.com</a:t>
-            </a:r>
-            <a:endParaRPr lang="en-US" sz="1100" dirty="0"/>
+              <a:t>As a compliance officer, I want an auditable reasoning trail for every claim decision, so I can demonstrate defensibility to CMS and internal audit.</a:t>
+            </a:r>
+            <a:endParaRPr lang="en-US" sz="1150" dirty="0"/>
+          </a:p>
+        </p:txBody>
+      </p:sp>
+      <p:sp>
+        <p:nvSpPr>
+          <p:cNvPr id="19" name="Shape 14"/>
+          <p:cNvSpPr/>
+          <p:nvPr/>
+        </p:nvSpPr>
+        <p:spPr>
+          <a:xfrm>
+            <a:off x="548640" y="4425696"/>
+            <a:ext cx="11064240" cy="822960"/>
+          </a:xfrm>
+          <a:prstGeom prst="roundRect">
+            <a:avLst>
+              <a:gd name="adj" fmla="val 8889"/>
+            </a:avLst>
+          </a:prstGeom>
+          <a:solidFill>
+            <a:srgbClr val="FAFAF9"/>
+          </a:solidFill>
+          <a:ln w="12700">
+            <a:solidFill>
+              <a:srgbClr val="ECECE9"/>
+            </a:solidFill>
+            <a:prstDash val="solid"/>
+          </a:ln>
+        </p:spPr>
+      </p:sp>
+      <p:sp>
+        <p:nvSpPr>
+          <p:cNvPr id="20" name="Shape 15"/>
+          <p:cNvSpPr/>
+          <p:nvPr/>
+        </p:nvSpPr>
+        <p:spPr>
+          <a:xfrm>
+            <a:off x="749808" y="4590288"/>
+            <a:ext cx="493776" cy="493776"/>
+          </a:xfrm>
+          <a:prstGeom prst="ellipse">
+            <a:avLst/>
+          </a:prstGeom>
+          <a:solidFill>
+            <a:srgbClr val="CCFBF1"/>
+          </a:solidFill>
+          <a:ln/>
+        </p:spPr>
+      </p:sp>
+      <p:pic>
+        <p:nvPicPr>
+          <p:cNvPr id="21" name="Image 3" descr="preencoded.png"/>
+          <p:cNvPicPr>
+            <a:picLocks noChangeAspect="1"/>
+          </p:cNvPicPr>
+          <p:nvPr/>
+        </p:nvPicPr>
+        <p:blipFill>
+          <a:blip r:embed="rId6"/>
+          <a:stretch>
+            <a:fillRect/>
+          </a:stretch>
+        </p:blipFill>
+        <p:spPr>
+          <a:xfrm>
+            <a:off x="878190" y="4718670"/>
+            <a:ext cx="237012" cy="237012"/>
+          </a:xfrm>
+          <a:prstGeom prst="rect">
+            <a:avLst/>
+          </a:prstGeom>
+        </p:spPr>
+      </p:pic>
+      <p:sp>
+        <p:nvSpPr>
+          <p:cNvPr id="22" name="Text 16"/>
+          <p:cNvSpPr/>
+          <p:nvPr/>
+        </p:nvSpPr>
+        <p:spPr>
+          <a:xfrm>
+            <a:off x="1417320" y="4517136"/>
+            <a:ext cx="2331720" cy="640080"/>
+          </a:xfrm>
+          <a:prstGeom prst="rect">
+            <a:avLst/>
+          </a:prstGeom>
+          <a:noFill/>
+          <a:ln/>
+        </p:spPr>
+        <p:txBody>
+          <a:bodyPr wrap="square" rtlCol="0" anchor="ctr"/>
+          <a:lstStyle/>
+          <a:p>
+            <a:pPr marL="0" indent="0">
+              <a:lnSpc>
+                <a:spcPts val="1600"/>
+              </a:lnSpc>
+              <a:buNone/>
+            </a:pPr>
+            <a:r>
+              <a:rPr lang="en-US" sz="1350" b="1" dirty="0">
+                <a:solidFill>
+                  <a:srgbClr val="1E1B4B"/>
+                </a:solidFill>
+                <a:latin typeface="Cambria" pitchFamily="34" charset="0"/>
+                <a:ea typeface="Cambria" pitchFamily="34" charset="-122"/>
+                <a:cs typeface="Cambria" pitchFamily="34" charset="-120"/>
+              </a:rPr>
+              <a:t>Operations Manager</a:t>
+            </a:r>
+            <a:endParaRPr lang="en-US" sz="1350" dirty="0"/>
+          </a:p>
+        </p:txBody>
+      </p:sp>
+      <p:sp>
+        <p:nvSpPr>
+          <p:cNvPr id="23" name="Text 17"/>
+          <p:cNvSpPr/>
+          <p:nvPr/>
+        </p:nvSpPr>
+        <p:spPr>
+          <a:xfrm>
+            <a:off x="3931920" y="4498848"/>
+            <a:ext cx="7406640" cy="676656"/>
+          </a:xfrm>
+          <a:prstGeom prst="rect">
+            <a:avLst/>
+          </a:prstGeom>
+          <a:noFill/>
+          <a:ln/>
+        </p:spPr>
+        <p:txBody>
+          <a:bodyPr wrap="square" rtlCol="0" anchor="ctr"/>
+          <a:lstStyle/>
+          <a:p>
+            <a:pPr marL="0" indent="0">
+              <a:lnSpc>
+                <a:spcPts val="1500"/>
+              </a:lnSpc>
+              <a:buNone/>
+            </a:pPr>
+            <a:r>
+              <a:rPr lang="en-US" sz="1150" dirty="0">
+                <a:solidFill>
+                  <a:srgbClr val="1A1A1A"/>
+                </a:solidFill>
+                <a:latin typeface="Calibri" pitchFamily="34" charset="0"/>
+                <a:ea typeface="Calibri" pitchFamily="34" charset="-122"/>
+                <a:cs typeface="Calibri" pitchFamily="34" charset="-120"/>
+              </a:rPr>
+              <a:t>As an operations manager, I want to upload our own claims data, so I can test the agent against real billing patterns, not just synthetic examples.</a:t>
+            </a:r>
+            <a:endParaRPr lang="en-US" sz="1150" dirty="0"/>
+          </a:p>
+        </p:txBody>
+      </p:sp>
+      <p:sp>
+        <p:nvSpPr>
+          <p:cNvPr id="24" name="Shape 18"/>
+          <p:cNvSpPr/>
+          <p:nvPr/>
+        </p:nvSpPr>
+        <p:spPr>
+          <a:xfrm>
+            <a:off x="548640" y="5358384"/>
+            <a:ext cx="11064240" cy="822960"/>
+          </a:xfrm>
+          <a:prstGeom prst="roundRect">
+            <a:avLst>
+              <a:gd name="adj" fmla="val 8889"/>
+            </a:avLst>
+          </a:prstGeom>
+          <a:solidFill>
+            <a:srgbClr val="FAFAF9"/>
+          </a:solidFill>
+          <a:ln w="12700">
+            <a:solidFill>
+              <a:srgbClr val="ECECE9"/>
+            </a:solidFill>
+            <a:prstDash val="solid"/>
+          </a:ln>
+        </p:spPr>
+      </p:sp>
+      <p:sp>
+        <p:nvSpPr>
+          <p:cNvPr id="25" name="Shape 19"/>
+          <p:cNvSpPr/>
+          <p:nvPr/>
+        </p:nvSpPr>
+        <p:spPr>
+          <a:xfrm>
+            <a:off x="749808" y="5522976"/>
+            <a:ext cx="493776" cy="493776"/>
+          </a:xfrm>
+          <a:prstGeom prst="ellipse">
+            <a:avLst/>
+          </a:prstGeom>
+          <a:solidFill>
+            <a:srgbClr val="FDE7E3"/>
+          </a:solidFill>
+          <a:ln/>
+        </p:spPr>
+      </p:sp>
+      <p:pic>
+        <p:nvPicPr>
+          <p:cNvPr id="26" name="Image 4" descr="preencoded.png"/>
+          <p:cNvPicPr>
+            <a:picLocks noChangeAspect="1"/>
+          </p:cNvPicPr>
+          <p:nvPr/>
+        </p:nvPicPr>
+        <p:blipFill>
+          <a:blip r:embed="rId7"/>
+          <a:stretch>
+            <a:fillRect/>
+          </a:stretch>
+        </p:blipFill>
+        <p:spPr>
+          <a:xfrm>
+            <a:off x="878190" y="5651358"/>
+            <a:ext cx="237012" cy="237012"/>
+          </a:xfrm>
+          <a:prstGeom prst="rect">
+            <a:avLst/>
+          </a:prstGeom>
+        </p:spPr>
+      </p:pic>
+      <p:sp>
+        <p:nvSpPr>
+          <p:cNvPr id="27" name="Text 20"/>
+          <p:cNvSpPr/>
+          <p:nvPr/>
+        </p:nvSpPr>
+        <p:spPr>
+          <a:xfrm>
+            <a:off x="1417320" y="5449824"/>
+            <a:ext cx="2331720" cy="640080"/>
+          </a:xfrm>
+          <a:prstGeom prst="rect">
+            <a:avLst/>
+          </a:prstGeom>
+          <a:noFill/>
+          <a:ln/>
+        </p:spPr>
+        <p:txBody>
+          <a:bodyPr wrap="square" rtlCol="0" anchor="ctr"/>
+          <a:lstStyle/>
+          <a:p>
+            <a:pPr marL="0" indent="0">
+              <a:lnSpc>
+                <a:spcPts val="1600"/>
+              </a:lnSpc>
+              <a:buNone/>
+            </a:pPr>
+            <a:r>
+              <a:rPr lang="en-US" sz="1350" b="1" dirty="0">
+                <a:solidFill>
+                  <a:srgbClr val="1E1B4B"/>
+                </a:solidFill>
+                <a:latin typeface="Cambria" pitchFamily="34" charset="0"/>
+                <a:ea typeface="Cambria" pitchFamily="34" charset="-122"/>
+                <a:cs typeface="Cambria" pitchFamily="34" charset="-120"/>
+              </a:rPr>
+              <a:t>Provider Relations Manager</a:t>
+            </a:r>
+            <a:endParaRPr lang="en-US" sz="1350" dirty="0"/>
+          </a:p>
+        </p:txBody>
+      </p:sp>
+      <p:sp>
+        <p:nvSpPr>
+          <p:cNvPr id="28" name="Text 21"/>
+          <p:cNvSpPr/>
+          <p:nvPr/>
+        </p:nvSpPr>
+        <p:spPr>
+          <a:xfrm>
+            <a:off x="3931920" y="5431536"/>
+            <a:ext cx="7406640" cy="676656"/>
+          </a:xfrm>
+          <a:prstGeom prst="rect">
+            <a:avLst/>
+          </a:prstGeom>
+          <a:noFill/>
+          <a:ln/>
+        </p:spPr>
+        <p:txBody>
+          <a:bodyPr wrap="square" rtlCol="0" anchor="ctr"/>
+          <a:lstStyle/>
+          <a:p>
+            <a:pPr marL="0" indent="0">
+              <a:lnSpc>
+                <a:spcPts val="1500"/>
+              </a:lnSpc>
+              <a:buNone/>
+            </a:pPr>
+            <a:r>
+              <a:rPr lang="en-US" sz="1150" dirty="0">
+                <a:solidFill>
+                  <a:srgbClr val="1A1A1A"/>
+                </a:solidFill>
+                <a:latin typeface="Calibri" pitchFamily="34" charset="0"/>
+                <a:ea typeface="Calibri" pitchFamily="34" charset="-122"/>
+                <a:cs typeface="Calibri" pitchFamily="34" charset="-120"/>
+              </a:rPr>
+              <a:t>As a provider relations manager, I want the agent to minimize false positives on legitimate claims, so provider abrasion and appeal volume stay low.</a:t>
+            </a:r>
+            <a:endParaRPr lang="en-US" sz="1150" dirty="0"/>
           </a:p>
         </p:txBody>
       </p:sp>

</xml_diff>